<commit_message>
version simple et v2 élaborées du rapport
</commit_message>
<xml_diff>
--- a/docs/Shelf Scan.pptx
+++ b/docs/Shelf Scan.pptx
@@ -8,13 +8,13 @@
     <p:sldId id="275" r:id="rId2"/>
     <p:sldId id="277" r:id="rId3"/>
     <p:sldId id="278" r:id="rId4"/>
-    <p:sldId id="279" r:id="rId5"/>
-    <p:sldId id="280" r:id="rId6"/>
+    <p:sldId id="286" r:id="rId5"/>
+    <p:sldId id="287" r:id="rId6"/>
     <p:sldId id="281" r:id="rId7"/>
     <p:sldId id="282" r:id="rId8"/>
     <p:sldId id="283" r:id="rId9"/>
     <p:sldId id="284" r:id="rId10"/>
-    <p:sldId id="285" r:id="rId11"/>
+    <p:sldId id="288" r:id="rId11"/>
   </p:sldIdLst>
   <p:sldSz cx="12192000" cy="6858000"/>
   <p:notesSz cx="6858000" cy="9144000"/>
@@ -113,6 +113,11 @@
       </a:defRPr>
     </a:lvl9pPr>
   </p:defaultTextStyle>
+  <p:extLst>
+    <p:ext uri="{EFAFB233-063F-42B5-8137-9DF3F51BA10A}">
+      <p15:sldGuideLst xmlns:p15="http://schemas.microsoft.com/office/powerpoint/2012/main"/>
+    </p:ext>
+  </p:extLst>
 </p:presentation>
 </file>
 
@@ -263,7 +268,7 @@
           <a:p>
             <a:fld id="{002DBFE5-08F8-CE40-8AA4-90CB853B5E08}" type="datetimeFigureOut">
               <a:rPr lang="fr-FR" smtClean="0"/>
-              <a:t>09/03/2026</a:t>
+              <a:t>10/03/2026</a:t>
             </a:fld>
             <a:endParaRPr lang="fr-FR"/>
           </a:p>
@@ -461,7 +466,7 @@
           <a:p>
             <a:fld id="{002DBFE5-08F8-CE40-8AA4-90CB853B5E08}" type="datetimeFigureOut">
               <a:rPr lang="fr-FR" smtClean="0"/>
-              <a:t>09/03/2026</a:t>
+              <a:t>10/03/2026</a:t>
             </a:fld>
             <a:endParaRPr lang="fr-FR"/>
           </a:p>
@@ -669,7 +674,7 @@
           <a:p>
             <a:fld id="{002DBFE5-08F8-CE40-8AA4-90CB853B5E08}" type="datetimeFigureOut">
               <a:rPr lang="fr-FR" smtClean="0"/>
-              <a:t>09/03/2026</a:t>
+              <a:t>10/03/2026</a:t>
             </a:fld>
             <a:endParaRPr lang="fr-FR"/>
           </a:p>
@@ -867,7 +872,7 @@
           <a:p>
             <a:fld id="{002DBFE5-08F8-CE40-8AA4-90CB853B5E08}" type="datetimeFigureOut">
               <a:rPr lang="fr-FR" smtClean="0"/>
-              <a:t>09/03/2026</a:t>
+              <a:t>10/03/2026</a:t>
             </a:fld>
             <a:endParaRPr lang="fr-FR"/>
           </a:p>
@@ -1142,7 +1147,7 @@
           <a:p>
             <a:fld id="{002DBFE5-08F8-CE40-8AA4-90CB853B5E08}" type="datetimeFigureOut">
               <a:rPr lang="fr-FR" smtClean="0"/>
-              <a:t>09/03/2026</a:t>
+              <a:t>10/03/2026</a:t>
             </a:fld>
             <a:endParaRPr lang="fr-FR"/>
           </a:p>
@@ -1407,7 +1412,7 @@
           <a:p>
             <a:fld id="{002DBFE5-08F8-CE40-8AA4-90CB853B5E08}" type="datetimeFigureOut">
               <a:rPr lang="fr-FR" smtClean="0"/>
-              <a:t>09/03/2026</a:t>
+              <a:t>10/03/2026</a:t>
             </a:fld>
             <a:endParaRPr lang="fr-FR"/>
           </a:p>
@@ -1819,7 +1824,7 @@
           <a:p>
             <a:fld id="{002DBFE5-08F8-CE40-8AA4-90CB853B5E08}" type="datetimeFigureOut">
               <a:rPr lang="fr-FR" smtClean="0"/>
-              <a:t>09/03/2026</a:t>
+              <a:t>10/03/2026</a:t>
             </a:fld>
             <a:endParaRPr lang="fr-FR"/>
           </a:p>
@@ -1960,7 +1965,7 @@
           <a:p>
             <a:fld id="{002DBFE5-08F8-CE40-8AA4-90CB853B5E08}" type="datetimeFigureOut">
               <a:rPr lang="fr-FR" smtClean="0"/>
-              <a:t>09/03/2026</a:t>
+              <a:t>10/03/2026</a:t>
             </a:fld>
             <a:endParaRPr lang="fr-FR"/>
           </a:p>
@@ -2073,7 +2078,7 @@
           <a:p>
             <a:fld id="{002DBFE5-08F8-CE40-8AA4-90CB853B5E08}" type="datetimeFigureOut">
               <a:rPr lang="fr-FR" smtClean="0"/>
-              <a:t>09/03/2026</a:t>
+              <a:t>10/03/2026</a:t>
             </a:fld>
             <a:endParaRPr lang="fr-FR"/>
           </a:p>
@@ -2384,7 +2389,7 @@
           <a:p>
             <a:fld id="{002DBFE5-08F8-CE40-8AA4-90CB853B5E08}" type="datetimeFigureOut">
               <a:rPr lang="fr-FR" smtClean="0"/>
-              <a:t>09/03/2026</a:t>
+              <a:t>10/03/2026</a:t>
             </a:fld>
             <a:endParaRPr lang="fr-FR"/>
           </a:p>
@@ -2672,7 +2677,7 @@
           <a:p>
             <a:fld id="{002DBFE5-08F8-CE40-8AA4-90CB853B5E08}" type="datetimeFigureOut">
               <a:rPr lang="fr-FR" smtClean="0"/>
-              <a:t>09/03/2026</a:t>
+              <a:t>10/03/2026</a:t>
             </a:fld>
             <a:endParaRPr lang="fr-FR"/>
           </a:p>
@@ -2924,7 +2929,7 @@
           <a:p>
             <a:fld id="{002DBFE5-08F8-CE40-8AA4-90CB853B5E08}" type="datetimeFigureOut">
               <a:rPr lang="fr-FR" smtClean="0"/>
-              <a:t>09/03/2026</a:t>
+              <a:t>10/03/2026</a:t>
             </a:fld>
             <a:endParaRPr lang="fr-FR"/>
           </a:p>
@@ -3598,10 +3603,15 @@
             <p:ph idx="1"/>
           </p:nvPr>
         </p:nvSpPr>
-        <p:spPr/>
+        <p:spPr>
+          <a:xfrm>
+            <a:off x="838200" y="1825625"/>
+            <a:ext cx="10515600" cy="3029547"/>
+          </a:xfrm>
+        </p:spPr>
         <p:txBody>
           <a:bodyPr>
-            <a:normAutofit/>
+            <a:spAutoFit/>
           </a:bodyPr>
           <a:lstStyle/>
           <a:p>
@@ -3614,7 +3624,7 @@
                   <a:srgbClr val="3498DB"/>
                 </a:solidFill>
               </a:rPr>
-              <a:t>Court terme — Valider le POC</a:t>
+              <a:t>Court terme — Consolider le POC</a:t>
             </a:r>
           </a:p>
           <a:p>
@@ -3628,7 +3638,7 @@
                   <a:srgbClr val="C8D6E5"/>
                 </a:solidFill>
               </a:rPr>
-              <a:t>Constituer le dataset de 20-30 photos annotées</a:t>
+              <a:t>Enrichir le dataset existant (15 images → 30+ photos annotées)</a:t>
             </a:r>
           </a:p>
           <a:p>
@@ -3642,7 +3652,7 @@
                   <a:srgbClr val="C8D6E5"/>
                 </a:solidFill>
               </a:rPr>
-              <a:t>Comparer PaddleOCR / TrOCR / Tesseract</a:t>
+              <a:t>Affiner le benchmark PaddleOCR / TrOCR / Tesseract (déjà initié)</a:t>
             </a:r>
           </a:p>
           <a:p>
@@ -3762,7 +3772,7 @@
     </p:spTree>
     <p:extLst>
       <p:ext uri="{BB962C8B-B14F-4D97-AF65-F5344CB8AC3E}">
-        <p14:creationId xmlns:p14="http://schemas.microsoft.com/office/powerpoint/2010/main" val="4242889346"/>
+        <p14:creationId xmlns:p14="http://schemas.microsoft.com/office/powerpoint/2010/main" val="2629321659"/>
       </p:ext>
     </p:extLst>
   </p:cSld>
@@ -4231,10 +4241,15 @@
             <p:ph idx="1"/>
           </p:nvPr>
         </p:nvSpPr>
-        <p:spPr/>
+        <p:spPr>
+          <a:xfrm>
+            <a:off x="838200" y="1825625"/>
+            <a:ext cx="10515600" cy="1320361"/>
+          </a:xfrm>
+        </p:spPr>
         <p:txBody>
           <a:bodyPr>
-            <a:normAutofit/>
+            <a:spAutoFit/>
           </a:bodyPr>
           <a:lstStyle/>
           <a:p>
@@ -4288,7 +4303,7 @@
                 </a:solidFill>
                 <a:latin typeface="Open Sans"/>
               </a:rPr>
-              <a:t>liste structurée (titre, auteur, éditeur)</a:t>
+              <a:t>liste structurée (titre, auteur, ISBN)</a:t>
             </a:r>
           </a:p>
           <a:p>
@@ -4350,7 +4365,7 @@
     </p:spTree>
     <p:extLst>
       <p:ext uri="{BB962C8B-B14F-4D97-AF65-F5344CB8AC3E}">
-        <p14:creationId xmlns:p14="http://schemas.microsoft.com/office/powerpoint/2010/main" val="4216527497"/>
+        <p14:creationId xmlns:p14="http://schemas.microsoft.com/office/powerpoint/2010/main" val="1350128388"/>
       </p:ext>
     </p:extLst>
   </p:cSld>
@@ -4526,7 +4541,7 @@
                   <a:srgbClr val="C8D6E5"/>
                 </a:solidFill>
               </a:rPr>
-              <a:t>Contraste, perspective</a:t>
+              <a:t>Contraste (CLAHE)</a:t>
             </a:r>
           </a:p>
         </p:txBody>
@@ -4997,7 +5012,7 @@
     </p:spTree>
     <p:extLst>
       <p:ext uri="{BB962C8B-B14F-4D97-AF65-F5344CB8AC3E}">
-        <p14:creationId xmlns:p14="http://schemas.microsoft.com/office/powerpoint/2010/main" val="663348104"/>
+        <p14:creationId xmlns:p14="http://schemas.microsoft.com/office/powerpoint/2010/main" val="4060463958"/>
       </p:ext>
     </p:extLst>
   </p:cSld>
@@ -5074,7 +5089,13 @@
           <p:cNvGraphicFramePr>
             <a:graphicFrameLocks noGrp="1"/>
           </p:cNvGraphicFramePr>
-          <p:nvPr/>
+          <p:nvPr>
+            <p:extLst>
+              <p:ext uri="{D42A27DB-BD31-4B8C-83A1-F6EECF244321}">
+                <p14:modId xmlns:p14="http://schemas.microsoft.com/office/powerpoint/2010/main" val="1424104921"/>
+              </p:ext>
+            </p:extLst>
+          </p:nvPr>
         </p:nvGraphicFramePr>
         <p:xfrm>
           <a:off x="1524000" y="1778000"/>
@@ -5310,7 +5331,7 @@
                           <a:ea typeface="Open Sans"/>
                           <a:cs typeface="Open Sans"/>
                         </a:rPr>
-                        <a:t>CRAFT / PaddleOCR</a:t>
+                        <a:t>PaddleOCR (DB-Net)</a:t>
                       </a:r>
                     </a:p>
                   </a:txBody>
@@ -5538,7 +5559,7 @@
                           <a:ea typeface="Open Sans"/>
                           <a:cs typeface="Open Sans"/>
                         </a:rPr>
-                        <a:t>Streamlit ou Gradio</a:t>
+                        <a:t>Streamlit</a:t>
                       </a:r>
                     </a:p>
                   </a:txBody>
@@ -7192,7 +7213,7 @@
 
 <file path=ppt/webextensions/taskpanes.xml><?xml version="1.0" encoding="utf-8"?>
 <wetp:taskpanes xmlns:wetp="http://schemas.microsoft.com/office/webextensions/taskpanes/2010/11">
-  <wetp:taskpane dockstate="right" visibility="0" width="350" row="0">
+  <wetp:taskpane dockstate="right" visibility="0" width="525" row="0">
     <wetp:webextensionref xmlns:r="http://schemas.openxmlformats.org/officeDocument/2006/relationships" r:id="rId1"/>
   </wetp:taskpane>
 </wetp:taskpanes>

</xml_diff>